<commit_message>
W01 D2 morning deck: labelled S12 lines and week 11, coloured and labelled S33 bars, positive notes
S12 names the Q1 and Q2 lines, labels their closing values and marks where
the tile stops at week 11. S33 draws the averaged roll-up in pink and the
weighted one in green, each bar with its value. Six 'X, not Y' lines in the
notes and the S32 title are rewritten as plain statements. Rebuilt through
build_deck.py on mermaid-cli 11.17.0.

Co-Authored-By: Claude Opus 5.5 <noreply@anthropic.com>
Claude-Session: https://claude.ai/code/session_01NDq7Sv6UNg6oqbgZGtNeM1
</commit_message>
<xml_diff>
--- a/content/W01/D2/slides/C2_W01_D02_half1_STUDENT.pptx
+++ b/content/W01/D2/slides/C2_W01_D02_half1_STUDENT.pptx
@@ -2067,12 +2067,17 @@
           <a:lstStyle/>
           <a:p>
             <a:r>
-              <a:t>LIVE, 4 minutes. This is the round's trap. The hurried default silences the error and the story</a:t>
-            </a:r>
-          </a:p>
-          <a:p>
-            <a:r>
-              <a:t>writes itself: discounts fell 8.0 percent, members pulled back, restore the discounts. The three</a:t>
+              <a:t>LIVE, 4 minutes. This is the round's trap. The hurried default silences the error, and the share of</a:t>
+            </a:r>
+          </a:p>
+          <a:p>
+            <a:r>
+              <a:t>Q2 orders with a discount above zero comes out at 50.0 percent, 43 of 86. The story writes itself:</a:t>
+            </a:r>
+          </a:p>
+          <a:p>
+            <a:r>
+              <a:t>half the orders went without, so Marketing extends the monsoon discount to the other half. The three</a:t>
             </a:r>
           </a:p>
           <a:p>
@@ -2082,7 +2087,7 @@
           </a:p>
           <a:p>
             <a:r>
-              <a:t>unknown. The default of zero erases the difference, and the total becomes a floor nobody labelled.</a:t>
+              <a:t>unknown. The default of zero files C beside B, and the share becomes a floor nobody labelled.</a:t>
             </a:r>
           </a:p>
         </p:txBody>
@@ -2152,12 +2157,17 @@
           <a:lstStyle/>
           <a:p>
             <a:r>
-              <a:t>LIVE, 3 minutes. Before running, each learner counts the orders that record the field in each</a:t>
-            </a:r>
-          </a:p>
-          <a:p>
-            <a:r>
-              <a:t>quarter in the empty your-turn cell of notebook 02. Nobody reads a count aloud. Then take letters.</a:t>
+              <a:t>LIVE, 3 minutes. Before the answer, each learner runs the count in the empty your-turn cell of</a:t>
+            </a:r>
+          </a:p>
+          <a:p>
+            <a:r>
+              <a:t>notebook 02: orders with no discount field, per quarter. Then take letters. Anyone who says a) has</a:t>
+            </a:r>
+          </a:p>
+          <a:p>
+            <a:r>
+              <a:t>not yet separated a recorded zero from a field nobody wrote.</a:t>
             </a:r>
           </a:p>
         </p:txBody>
@@ -2227,32 +2237,32 @@
           <a:lstStyle/>
           <a:p>
             <a:r>
-              <a:t>LIVE, 5 minutes. The answer is d: the direction flipped. Three moves. First, the decision goes in</a:t>
-            </a:r>
-          </a:p>
-          <a:p>
-            <a:r>
-              <a:t>writing beside the number. Second, ask who wrote the records without the field: an older checkout, a</a:t>
-            </a:r>
-          </a:p>
-          <a:p>
-            <a:r>
-              <a:t>channel, a batch. Statisticians separate data missing at random from data missing for a reason</a:t>
-            </a:r>
-          </a:p>
-          <a:p>
-            <a:r>
-              <a:t>(Rubin, 1976, "Inference and missing data", Biometrika); the business version is "which system</a:t>
-            </a:r>
-          </a:p>
-          <a:p>
-            <a:r>
-              <a:t>left it empty, and does that system sell differently?". Third, a bound: the largest recorded</a:t>
-            </a:r>
-          </a:p>
-          <a:p>
-            <a:r>
-              <a:t>discount is Rs 150, so the branch is at most Rs 12,900 against Rs 23,00,000, under one percent.</a:t>
+              <a:t>LIVE, 5 minutes. The answer is c: 17 recorded zeros and 26 records with no field. Three moves.</a:t>
+            </a:r>
+          </a:p>
+          <a:p>
+            <a:r>
+              <a:t>First, the decision goes in writing beside the number. Second, ask who wrote the records without the</a:t>
+            </a:r>
+          </a:p>
+          <a:p>
+            <a:r>
+              <a:t>field: an older checkout, a channel, a batch. Statisticians separate data missing at random from</a:t>
+            </a:r>
+          </a:p>
+          <a:p>
+            <a:r>
+              <a:t>data missing for a reason (Rubin, 1976, "Inference and missing data", Biometrika); the business</a:t>
+            </a:r>
+          </a:p>
+          <a:p>
+            <a:r>
+              <a:t>version is "which system left it empty, and does that system sell differently?". Third, a bound: the</a:t>
+            </a:r>
+          </a:p>
+          <a:p>
+            <a:r>
+              <a:t>share lies between 50.0 and 80.2 percent, and in rupees the branch is under one percent of the fall.</a:t>
             </a:r>
           </a:p>
           <a:p>
@@ -2672,7 +2682,7 @@
           </a:p>
           <a:p>
             <a:r>
-              <a:t>whether it is everyone. This table is a lens, not an answer: it says which number to read first for</a:t>
+              <a:t>whether it is everyone. This table is a lens that points the question: it says which number to read first for</a:t>
             </a:r>
           </a:p>
           <a:p>
@@ -3362,7 +3372,7 @@
           </a:p>
           <a:p>
             <a:r>
-              <a:t>acquire, so it reads every fall as an acquisition problem; that is structure, not bad faith. The</a:t>
+              <a:t>acquire, so it reads every fall as an acquisition problem; that is how the role is paid, and it says nothing about good faith. The</a:t>
             </a:r>
           </a:p>
           <a:p>
@@ -3622,7 +3632,7 @@
           </a:p>
           <a:p>
             <a:r>
-              <a:t>quantity. The HBR figures are published estimates across industries, not Kalpa's numbers; say so.</a:t>
+              <a:t>quantity. The HBR figures are published estimates across industries, and Kalpa has none of its own yet; say so.</a:t>
             </a:r>
           </a:p>
           <a:p>
@@ -3717,7 +3727,7 @@
           </a:p>
           <a:p>
             <a:r>
-              <a:t>the system, not only in the arithmetic: where the data is written, moved and summarised. Keep every</a:t>
+              <a:t>the system as well as in the arithmetic: where the data is written, moved and summarised. Keep every</a:t>
             </a:r>
           </a:p>
           <a:p>
@@ -3807,12 +3817,12 @@
           </a:p>
           <a:p>
             <a:r>
-              <a:t>dashboard's roll-up. Engineers in a GCC are asked this constantly: the drop was a pipeline, not a</a:t>
-            </a:r>
-          </a:p>
-          <a:p>
-            <a:r>
-              <a:t>market. Checking the pipeline first is the cheapest investigation there is.</a:t>
+              <a:t>dashboard's roll-up. Engineers in a GCC are asked this constantly: the drop sat in a</a:t>
+            </a:r>
+          </a:p>
+          <a:p>
+            <a:r>
+              <a:t>pipeline while the market held. Checking the pipeline first is the cheapest investigation there is.</a:t>
             </a:r>
           </a:p>
         </p:txBody>
@@ -8196,7 +8206,7 @@
                 </a:solidFill>
                 <a:latin typeface="Calibri"/>
               </a:rPr>
-              <a:t>Week 1 Day 2: which branch moved</a:t>
+              <a:t>Week 1, Day 2. Which branch moved</a:t>
             </a:r>
           </a:p>
         </p:txBody>
@@ -12498,7 +12508,7 @@
       </p:sp>
       <p:pic>
         <p:nvPicPr>
-          <p:cNvPr id="9" name="mermaid diagram" descr="275444f253222592.png"/>
+          <p:cNvPr id="9" name="mermaid diagram" descr="0f9efb18d998f26c.png"/>
           <p:cNvPicPr>
             <a:picLocks noChangeAspect="1"/>
           </p:cNvPicPr>
@@ -17529,7 +17539,7 @@
                 </a:solidFill>
                 <a:latin typeface="Calibri"/>
               </a:rPr>
-              <a:t>Week 1 Day 2: which branch moved</a:t>
+              <a:t>Week 1, Day 2. Which branch moved</a:t>
             </a:r>
           </a:p>
         </p:txBody>
@@ -18095,7 +18105,7 @@
                 </a:solidFill>
                 <a:latin typeface="Calibri"/>
               </a:rPr>
-              <a:t>Week 1 Day 2: which branch moved</a:t>
+              <a:t>Week 1, Day 2. Which branch moved</a:t>
             </a:r>
           </a:p>
         </p:txBody>
@@ -23822,7 +23832,7 @@
                 </a:solidFill>
                 <a:latin typeface="Georgia"/>
               </a:rPr>
-              <a:t>The wrong answer: discounts fell 8.0 percent</a:t>
+              <a:t>The wrong answer: half the orders had no discount</a:t>
             </a:r>
           </a:p>
         </p:txBody>
@@ -23857,14 +23867,14 @@
                 </a:solidFill>
                 <a:latin typeface="Calibri"/>
               </a:rPr>
-              <a:t>Reading a missing discount as zero gives a total, a story and a decision.</a:t>
+              <a:t>Reading a missing discount as zero gives a share, a story and a decision.</a:t>
             </a:r>
           </a:p>
         </p:txBody>
       </p:sp>
       <p:pic>
         <p:nvPicPr>
-          <p:cNvPr id="9" name="mermaid diagram" descr="13c8547a3e45438c.png"/>
+          <p:cNvPr id="9" name="mermaid diagram" descr="26cea2eaab6cb7bd.png"/>
           <p:cNvPicPr>
             <a:picLocks noChangeAspect="1"/>
           </p:cNvPicPr>
@@ -23878,8 +23888,8 @@
         </p:blipFill>
         <p:spPr>
           <a:xfrm>
-            <a:off x="2495397" y="1956816"/>
-            <a:ext cx="7200900" cy="1128712"/>
+            <a:off x="3095472" y="1956816"/>
+            <a:ext cx="6000750" cy="1128712"/>
           </a:xfrm>
           <a:prstGeom prst="rect">
             <a:avLst/>
@@ -23905,10 +23915,10 @@
                 <a:tableStyleId>{2D5ABB26-0587-4C30-8999-92F81FD0307C}</a:tableStyleId>
               </a:tblPr>
               <a:tblGrid>
-                <a:gridCol w="2915390"/>
-                <a:gridCol w="2915390"/>
-                <a:gridCol w="2561676"/>
-                <a:gridCol w="2738533"/>
+                <a:gridCol w="3491920"/>
+                <a:gridCol w="2710802"/>
+                <a:gridCol w="2381911"/>
+                <a:gridCol w="2546356"/>
               </a:tblGrid>
               <a:tr h="335280">
                 <a:tc>
@@ -24193,7 +24203,7 @@
                           </a:solidFill>
                           <a:latin typeface="Calibri"/>
                         </a:rPr>
-                        <a:t>Average</a:t>
+                        <a:t>Share with a discount</a:t>
                       </a:r>
                     </a:p>
                   </a:txBody>
@@ -24227,7 +24237,7 @@
                           </a:solidFill>
                           <a:latin typeface="Calibri"/>
                         </a:rPr>
-                        <a:t>Rs 33</a:t>
+                        <a:t>1 of 3, 33%</a:t>
                       </a:r>
                     </a:p>
                   </a:txBody>
@@ -24249,7 +24259,7 @@
                           </a:solidFill>
                           <a:latin typeface="Calibri"/>
                         </a:rPr>
-                        <a:t>Rs 50</a:t>
+                        <a:t>1 of 2, 50%</a:t>
                       </a:r>
                     </a:p>
                   </a:txBody>
@@ -24816,7 +24826,7 @@
                 </a:solidFill>
                 <a:latin typeface="Georgia"/>
               </a:rPr>
-              <a:t>Question: the average where a discount is recorded?</a:t>
+              <a:t>Question: what were the 43 "no discount" orders?</a:t>
             </a:r>
           </a:p>
         </p:txBody>
@@ -24851,7 +24861,7 @@
                 </a:solidFill>
                 <a:latin typeface="Calibri"/>
               </a:rPr>
-              <a:t>Q1 averages Rs 60.98 per order that records one; predict Q2.</a:t>
+              <a:t>The hurried reading says 43 of Q2's 86 orders went without; predict what they are.</a:t>
             </a:r>
           </a:p>
         </p:txBody>
@@ -24886,7 +24896,7 @@
                 </a:solidFill>
                 <a:latin typeface="Georgia"/>
               </a:rPr>
-              <a:t>Rs 43.86</a:t>
+              <a:t>42.1%</a:t>
             </a:r>
           </a:p>
         </p:txBody>
@@ -24956,7 +24966,7 @@
                 </a:solidFill>
                 <a:latin typeface="Calibri"/>
               </a:rPr>
-              <a:t>per order</a:t>
+              <a:t>orders with a discount</a:t>
             </a:r>
           </a:p>
         </p:txBody>
@@ -25035,7 +25045,7 @@
                 </a:solidFill>
                 <a:latin typeface="Georgia"/>
               </a:rPr>
-              <a:t>Rs 53.49</a:t>
+              <a:t>50.0%</a:t>
             </a:r>
           </a:p>
         </p:txBody>
@@ -25105,7 +25115,7 @@
                 </a:solidFill>
                 <a:latin typeface="Calibri"/>
               </a:rPr>
-              <a:t>per order</a:t>
+              <a:t>orders with a discount</a:t>
             </a:r>
           </a:p>
         </p:txBody>
@@ -25184,7 +25194,7 @@
                 </a:solidFill>
                 <a:latin typeface="Georgia"/>
               </a:rPr>
-              <a:t>Rs 60.98</a:t>
+              <a:t>43</a:t>
             </a:r>
           </a:p>
         </p:txBody>
@@ -25219,7 +25229,7 @@
                 </a:solidFill>
                 <a:latin typeface="Calibri"/>
               </a:rPr>
-              <a:t>Q1, RECORDED ONLY</a:t>
+              <a:t>Q2, READ AS NONE</a:t>
             </a:r>
           </a:p>
         </p:txBody>
@@ -25254,7 +25264,7 @@
                 </a:solidFill>
                 <a:latin typeface="Calibri"/>
               </a:rPr>
-              <a:t>per order that records it</a:t>
+              <a:t>of 86 orders</a:t>
             </a:r>
           </a:p>
         </p:txBody>
@@ -25435,7 +25445,7 @@
                 </a:solidFill>
                 <a:latin typeface="Calibri"/>
               </a:rPr>
-              <a:t>Predict Q2's average over orders that record a discount: a) Rs 53.49, the same; b) Rs 46.00, down; c) Rs 60.98, flat; d) Rs 76.67, up.</a:t>
+              <a:t>Of the 43 Q2 orders read as "no discount", how many record Rs 0? a) all 43; b) 34; c) 17; d) none.</a:t>
             </a:r>
           </a:p>
         </p:txBody>
@@ -25992,7 +26002,7 @@
                 </a:solidFill>
                 <a:latin typeface="Georgia"/>
               </a:rPr>
-              <a:t>Answer: up 25.7 percent, and a bound on the branch</a:t>
+              <a:t>Answer: 17 recorded zeros and 26 unknowns</a:t>
             </a:r>
           </a:p>
         </p:txBody>
@@ -26027,7 +26037,7 @@
                 </a:solidFill>
                 <a:latin typeface="Calibri"/>
               </a:rPr>
-              <a:t>Where it is recorded, the discount rose; and even at its worst, the branch is too small to matter.</a:t>
+              <a:t>Where the field is recorded, 71.7 percent of Q2's orders carry a discount, and the rest is a range.</a:t>
             </a:r>
           </a:p>
         </p:txBody>
@@ -26042,7 +26052,7 @@
         </p:nvGraphicFramePr>
         <p:xfrm>
           <a:off x="530352" y="1956816"/>
-          <a:ext cx="11130990" cy="1341120"/>
+          <a:ext cx="11130990" cy="1849120"/>
         </p:xfrm>
         <a:graphic>
           <a:graphicData uri="http://schemas.openxmlformats.org/drawingml/2006/table">
@@ -26051,25 +26061,24 @@
                 <a:tableStyleId>{2D5ABB26-0587-4C30-8999-92F81FD0307C}</a:tableStyleId>
               </a:tblPr>
               <a:tblGrid>
-                <a:gridCol w="5567157"/>
-                <a:gridCol w="914400"/>
-                <a:gridCol w="1498212"/>
-                <a:gridCol w="3151221"/>
+                <a:gridCol w="5667442"/>
+                <a:gridCol w="2808144"/>
+                <a:gridCol w="2655404"/>
               </a:tblGrid>
-              <a:tr h="335280">
+              <a:tr h="369824">
                 <a:tc>
                   <a:txBody>
                     <a:bodyPr/>
                     <a:lstStyle/>
                     <a:p>
                       <a:r>
-                        <a:rPr sz="1250" b="1" i="0">
+                        <a:rPr sz="1450" b="1" i="0">
                           <a:solidFill>
                             <a:srgbClr val="FFFFFF"/>
                           </a:solidFill>
                           <a:latin typeface="Calibri"/>
                         </a:rPr>
-                        <a:t>Reading</a:t>
+                        <a:t>Share of orders with a discount</a:t>
                       </a:r>
                     </a:p>
                   </a:txBody>
@@ -26085,7 +26094,7 @@
                     <a:lstStyle/>
                     <a:p>
                       <a:r>
-                        <a:rPr sz="1250" b="1" i="0">
+                        <a:rPr sz="1450" b="1" i="0">
                           <a:solidFill>
                             <a:srgbClr val="FFFFFF"/>
                           </a:solidFill>
@@ -26107,7 +26116,7 @@
                     <a:lstStyle/>
                     <a:p>
                       <a:r>
-                        <a:rPr sz="1250" b="1" i="0">
+                        <a:rPr sz="1450" b="1" i="0">
                           <a:solidFill>
                             <a:srgbClr val="FFFFFF"/>
                           </a:solidFill>
@@ -26123,43 +26132,21 @@
                     </a:solidFill>
                   </a:tcPr>
                 </a:tc>
+              </a:tr>
+              <a:tr h="369824">
                 <a:tc>
                   <a:txBody>
                     <a:bodyPr/>
                     <a:lstStyle/>
                     <a:p>
                       <a:r>
-                        <a:rPr sz="1250" b="1" i="0">
-                          <a:solidFill>
-                            <a:srgbClr val="FFFFFF"/>
-                          </a:solidFill>
-                          <a:latin typeface="Calibri"/>
-                        </a:rPr>
-                        <a:t>Change</a:t>
-                      </a:r>
-                    </a:p>
-                  </a:txBody>
-                  <a:tcPr marL="101600" marR="101600" marT="38100" marB="38100" anchor="ctr">
-                    <a:solidFill>
-                      <a:srgbClr val="1A0F5C"/>
-                    </a:solidFill>
-                  </a:tcPr>
-                </a:tc>
-              </a:tr>
-              <a:tr h="335280">
-                <a:tc>
-                  <a:txBody>
-                    <a:bodyPr/>
-                    <a:lstStyle/>
-                    <a:p>
-                      <a:r>
-                        <a:rPr sz="1200" b="0" i="0">
+                        <a:rPr sz="1400" b="0" i="0">
                           <a:solidFill>
                             <a:srgbClr val="1A1440"/>
                           </a:solidFill>
                           <a:latin typeface="Calibri"/>
                         </a:rPr>
-                        <a:t>Total, absent read as zero</a:t>
+                        <a:t>Blanks read as zero</a:t>
                       </a:r>
                     </a:p>
                   </a:txBody>
@@ -26175,13 +26162,13 @@
                     <a:lstStyle/>
                     <a:p>
                       <a:r>
-                        <a:rPr sz="1200" b="0" i="0">
+                        <a:rPr sz="1400" b="0" i="0">
                           <a:solidFill>
                             <a:srgbClr val="1A1440"/>
                           </a:solidFill>
                           <a:latin typeface="Calibri"/>
                         </a:rPr>
-                        <a:t>Rs 5,000</a:t>
+                        <a:t>42.1%, 48 of 114</a:t>
                       </a:r>
                     </a:p>
                   </a:txBody>
@@ -26197,13 +26184,105 @@
                     <a:lstStyle/>
                     <a:p>
                       <a:r>
-                        <a:rPr sz="1200" b="0" i="0">
+                        <a:rPr sz="1400" b="0" i="0">
                           <a:solidFill>
                             <a:srgbClr val="1A1440"/>
                           </a:solidFill>
                           <a:latin typeface="Calibri"/>
                         </a:rPr>
-                        <a:t>Rs 4,600</a:t>
+                        <a:t>50.0%, 43 of 86</a:t>
+                      </a:r>
+                    </a:p>
+                  </a:txBody>
+                  <a:tcPr marL="101600" marR="101600" marT="38100" marB="38100" anchor="ctr">
+                    <a:solidFill>
+                      <a:srgbClr val="FFFFFF"/>
+                    </a:solidFill>
+                  </a:tcPr>
+                </a:tc>
+              </a:tr>
+              <a:tr h="369824">
+                <a:tc>
+                  <a:txBody>
+                    <a:bodyPr/>
+                    <a:lstStyle/>
+                    <a:p>
+                      <a:r>
+                        <a:rPr sz="1400" b="0" i="0">
+                          <a:solidFill>
+                            <a:srgbClr val="1A1440"/>
+                          </a:solidFill>
+                          <a:latin typeface="Calibri"/>
+                        </a:rPr>
+                        <a:t>No discount field (the check)</a:t>
+                      </a:r>
+                    </a:p>
+                  </a:txBody>
+                  <a:tcPr marL="101600" marR="101600" marT="38100" marB="38100" anchor="ctr">
+                    <a:solidFill>
+                      <a:srgbClr val="F4F2FA"/>
+                    </a:solidFill>
+                  </a:tcPr>
+                </a:tc>
+                <a:tc>
+                  <a:txBody>
+                    <a:bodyPr/>
+                    <a:lstStyle/>
+                    <a:p>
+                      <a:r>
+                        <a:rPr sz="1400" b="0" i="0">
+                          <a:solidFill>
+                            <a:srgbClr val="1A1440"/>
+                          </a:solidFill>
+                          <a:latin typeface="Calibri"/>
+                        </a:rPr>
+                        <a:t>32 orders</a:t>
+                      </a:r>
+                    </a:p>
+                  </a:txBody>
+                  <a:tcPr marL="101600" marR="101600" marT="38100" marB="38100" anchor="ctr">
+                    <a:solidFill>
+                      <a:srgbClr val="F4F2FA"/>
+                    </a:solidFill>
+                  </a:tcPr>
+                </a:tc>
+                <a:tc>
+                  <a:txBody>
+                    <a:bodyPr/>
+                    <a:lstStyle/>
+                    <a:p>
+                      <a:r>
+                        <a:rPr sz="1400" b="0" i="0">
+                          <a:solidFill>
+                            <a:srgbClr val="1A1440"/>
+                          </a:solidFill>
+                          <a:latin typeface="Calibri"/>
+                        </a:rPr>
+                        <a:t>26 orders</a:t>
+                      </a:r>
+                    </a:p>
+                  </a:txBody>
+                  <a:tcPr marL="101600" marR="101600" marT="38100" marB="38100" anchor="ctr">
+                    <a:solidFill>
+                      <a:srgbClr val="F4F2FA"/>
+                    </a:solidFill>
+                  </a:tcPr>
+                </a:tc>
+              </a:tr>
+              <a:tr h="369824">
+                <a:tc>
+                  <a:txBody>
+                    <a:bodyPr/>
+                    <a:lstStyle/>
+                    <a:p>
+                      <a:r>
+                        <a:rPr sz="1400" b="0" i="0">
+                          <a:solidFill>
+                            <a:srgbClr val="1A1440"/>
+                          </a:solidFill>
+                          <a:latin typeface="Calibri"/>
+                        </a:rPr>
+                        <a:t>Over orders that record the field</a:t>
                       </a:r>
                     </a:p>
                   </a:txBody>
@@ -26219,13 +26298,35 @@
                     <a:lstStyle/>
                     <a:p>
                       <a:r>
-                        <a:rPr sz="1200" b="0" i="0">
+                        <a:rPr sz="1400" b="0" i="0">
                           <a:solidFill>
                             <a:srgbClr val="1A1440"/>
                           </a:solidFill>
                           <a:latin typeface="Calibri"/>
                         </a:rPr>
-                        <a:t>-8.0%</a:t>
+                        <a:t>58.5%, 48 of 82</a:t>
+                      </a:r>
+                    </a:p>
+                  </a:txBody>
+                  <a:tcPr marL="101600" marR="101600" marT="38100" marB="38100" anchor="ctr">
+                    <a:solidFill>
+                      <a:srgbClr val="FFFFFF"/>
+                    </a:solidFill>
+                  </a:tcPr>
+                </a:tc>
+                <a:tc>
+                  <a:txBody>
+                    <a:bodyPr/>
+                    <a:lstStyle/>
+                    <a:p>
+                      <a:r>
+                        <a:rPr sz="1400" b="0" i="0">
+                          <a:solidFill>
+                            <a:srgbClr val="1A1440"/>
+                          </a:solidFill>
+                          <a:latin typeface="Calibri"/>
+                        </a:rPr>
+                        <a:t>71.7%, 43 of 60</a:t>
                       </a:r>
                     </a:p>
                   </a:txBody>
@@ -26236,20 +26337,20 @@
                   </a:tcPr>
                 </a:tc>
               </a:tr>
-              <a:tr h="335280">
+              <a:tr h="369824">
                 <a:tc>
                   <a:txBody>
                     <a:bodyPr/>
                     <a:lstStyle/>
                     <a:p>
                       <a:r>
-                        <a:rPr sz="1200" b="0" i="0">
+                        <a:rPr sz="1400" b="0" i="0">
                           <a:solidFill>
                             <a:srgbClr val="1A1440"/>
                           </a:solidFill>
                           <a:latin typeface="Calibri"/>
                         </a:rPr>
-                        <a:t>Average, recorded only</a:t>
+                        <a:t>Range, blanks unknown</a:t>
                       </a:r>
                     </a:p>
                   </a:txBody>
@@ -26265,13 +26366,13 @@
                     <a:lstStyle/>
                     <a:p>
                       <a:r>
-                        <a:rPr sz="1200" b="0" i="0">
+                        <a:rPr sz="1400" b="0" i="0">
                           <a:solidFill>
                             <a:srgbClr val="1A1440"/>
                           </a:solidFill>
                           <a:latin typeface="Calibri"/>
                         </a:rPr>
-                        <a:t>Rs 60.98</a:t>
+                        <a:t>42.1% to 70.2%</a:t>
                       </a:r>
                     </a:p>
                   </a:txBody>
@@ -26287,35 +26388,13 @@
                     <a:lstStyle/>
                     <a:p>
                       <a:r>
-                        <a:rPr sz="1200" b="0" i="0">
+                        <a:rPr sz="1400" b="0" i="0">
                           <a:solidFill>
                             <a:srgbClr val="1A1440"/>
                           </a:solidFill>
                           <a:latin typeface="Calibri"/>
                         </a:rPr>
-                        <a:t>Rs 76.67</a:t>
-                      </a:r>
-                    </a:p>
-                  </a:txBody>
-                  <a:tcPr marL="101600" marR="101600" marT="38100" marB="38100" anchor="ctr">
-                    <a:solidFill>
-                      <a:srgbClr val="F4F2FA"/>
-                    </a:solidFill>
-                  </a:tcPr>
-                </a:tc>
-                <a:tc>
-                  <a:txBody>
-                    <a:bodyPr/>
-                    <a:lstStyle/>
-                    <a:p>
-                      <a:r>
-                        <a:rPr sz="1200" b="0" i="0">
-                          <a:solidFill>
-                            <a:srgbClr val="1A1440"/>
-                          </a:solidFill>
-                          <a:latin typeface="Calibri"/>
-                        </a:rPr>
-                        <a:t>+25.7%</a:t>
+                        <a:t>50.0% to 80.2%</a:t>
                       </a:r>
                     </a:p>
                   </a:txBody>
@@ -26326,86 +26405,6 @@
                   </a:tcPr>
                 </a:tc>
               </a:tr>
-              <a:tr h="335280">
-                <a:tc>
-                  <a:txBody>
-                    <a:bodyPr/>
-                    <a:lstStyle/>
-                    <a:p>
-                      <a:r>
-                        <a:rPr sz="1200" b="0" i="0">
-                          <a:solidFill>
-                            <a:srgbClr val="1A1440"/>
-                          </a:solidFill>
-                          <a:latin typeface="Calibri"/>
-                        </a:rPr>
-                        <a:t>Most Q2 could give, Rs 150 on every order</a:t>
-                      </a:r>
-                    </a:p>
-                  </a:txBody>
-                  <a:tcPr marL="101600" marR="101600" marT="38100" marB="38100" anchor="ctr">
-                    <a:solidFill>
-                      <a:srgbClr val="FFFFFF"/>
-                    </a:solidFill>
-                  </a:tcPr>
-                </a:tc>
-                <a:tc>
-                  <a:txBody>
-                    <a:bodyPr/>
-                    <a:lstStyle/>
-                    <a:p/>
-                  </a:txBody>
-                  <a:tcPr marL="101600" marR="101600" marT="38100" marB="38100" anchor="ctr">
-                    <a:solidFill>
-                      <a:srgbClr val="FFFFFF"/>
-                    </a:solidFill>
-                  </a:tcPr>
-                </a:tc>
-                <a:tc>
-                  <a:txBody>
-                    <a:bodyPr/>
-                    <a:lstStyle/>
-                    <a:p>
-                      <a:r>
-                        <a:rPr sz="1200" b="0" i="0">
-                          <a:solidFill>
-                            <a:srgbClr val="1A1440"/>
-                          </a:solidFill>
-                          <a:latin typeface="Calibri"/>
-                        </a:rPr>
-                        <a:t>Rs 12,900</a:t>
-                      </a:r>
-                    </a:p>
-                  </a:txBody>
-                  <a:tcPr marL="101600" marR="101600" marT="38100" marB="38100" anchor="ctr">
-                    <a:solidFill>
-                      <a:srgbClr val="FFFFFF"/>
-                    </a:solidFill>
-                  </a:tcPr>
-                </a:tc>
-                <a:tc>
-                  <a:txBody>
-                    <a:bodyPr/>
-                    <a:lstStyle/>
-                    <a:p>
-                      <a:r>
-                        <a:rPr sz="1200" b="0" i="0">
-                          <a:solidFill>
-                            <a:srgbClr val="1A1440"/>
-                          </a:solidFill>
-                          <a:latin typeface="Calibri"/>
-                        </a:rPr>
-                        <a:t>of a Rs 23,00,000 fall</a:t>
-                      </a:r>
-                    </a:p>
-                  </a:txBody>
-                  <a:tcPr marL="101600" marR="101600" marT="38100" marB="38100" anchor="ctr">
-                    <a:solidFill>
-                      <a:srgbClr val="FFFFFF"/>
-                    </a:solidFill>
-                  </a:tcPr>
-                </a:tc>
-              </a:tr>
             </a:tbl>
           </a:graphicData>
         </a:graphic>
@@ -26418,8 +26417,8 @@
         </p:nvSpPr>
         <p:spPr>
           <a:xfrm>
-            <a:off x="530352" y="3553968"/>
-            <a:ext cx="11130991" cy="1074420"/>
+            <a:off x="530352" y="4061968"/>
+            <a:ext cx="11130991" cy="1341120"/>
           </a:xfrm>
           <a:prstGeom prst="roundRect">
             <a:avLst>
@@ -26466,8 +26465,8 @@
         </p:nvSpPr>
         <p:spPr>
           <a:xfrm>
-            <a:off x="676656" y="3681984"/>
-            <a:ext cx="45720" cy="818388"/>
+            <a:off x="676656" y="4189983"/>
+            <a:ext cx="45720" cy="1085088"/>
           </a:xfrm>
           <a:prstGeom prst="roundRect">
             <a:avLst>
@@ -26512,8 +26511,8 @@
         </p:nvSpPr>
         <p:spPr>
           <a:xfrm>
-            <a:off x="877824" y="3672840"/>
-            <a:ext cx="10564063" cy="891540"/>
+            <a:off x="877824" y="4180840"/>
+            <a:ext cx="10564063" cy="1158240"/>
           </a:xfrm>
           <a:prstGeom prst="rect">
             <a:avLst/>
@@ -26542,7 +26541,7 @@
                 </a:solidFill>
                 <a:latin typeface="Calibri"/>
               </a:rPr>
-              <a:t>Write the default with its reason: "absent means not recorded; reported separately; never summed as zero". Absence is rarely random, because some system or channel decided not to write the field, so the recorded orders may not speak for the rest; the worst-case bound closes the branch without guessing.</a:t>
+              <a:t>Write the default with its reason: "absent means not recorded; reported separately; never counted as zero". Only 17 of Q2's 86 orders are known to have had no discount, so the extension loses its premise; and at Rs 150 on every Q2 order, the most anyone recorded, the branch holds at most Rs 12,900 of a Rs 23,00,000 fall.</a:t>
             </a:r>
           </a:p>
         </p:txBody>
@@ -31605,7 +31604,7 @@
                 </a:solidFill>
                 <a:latin typeface="Calibri"/>
               </a:rPr>
-              <a:t>Week 1 Day 2: which branch moved</a:t>
+              <a:t>Week 1, Day 2. Which branch moved</a:t>
             </a:r>
           </a:p>
         </p:txBody>
@@ -37075,7 +37074,7 @@
                 </a:solidFill>
                 <a:latin typeface="Georgia"/>
               </a:rPr>
-              <a:t>Answer: one order moved the range, not the middle</a:t>
+              <a:t>Answer: one order stretched the range; the middle held</a:t>
             </a:r>
           </a:p>
         </p:txBody>
@@ -38323,7 +38322,7 @@
       </p:sp>
       <p:pic>
         <p:nvPicPr>
-          <p:cNvPr id="9" name="mermaid diagram" descr="e5c4706c80eb9847.png"/>
+          <p:cNvPr id="9" name="mermaid diagram" descr="d36382270481ac5e.png"/>
           <p:cNvPicPr>
             <a:picLocks noChangeAspect="1"/>
           </p:cNvPicPr>

</xml_diff>